<commit_message>
Loosen inventory-gap card spacing (slide 11) so the mispriced callout doesn't crowd the footnote
Co-Authored-By: Claude Opus 4.8 <noreply@anthropic.com>
Claude-Session: https://claude.ai/code/session_015GFhuXGmyaJj72KB2tVx2U
</commit_message>
<xml_diff>
--- a/deck/assets/fill_batch2.pptx
+++ b/deck/assets/fill_batch2.pptx
@@ -4978,7 +4978,7 @@
         </p:nvSpPr>
         <p:spPr>
           <a:xfrm>
-            <a:off x="596900" y="2641600"/>
+            <a:off x="596900" y="2654300"/>
             <a:ext cx="4902200" cy="127000"/>
           </a:xfrm>
           <a:prstGeom prst="rect">
@@ -5023,7 +5023,7 @@
         </p:nvSpPr>
         <p:spPr>
           <a:xfrm>
-            <a:off x="596900" y="2882900"/>
+            <a:off x="596900" y="2921000"/>
             <a:ext cx="4902200" cy="127000"/>
           </a:xfrm>
           <a:prstGeom prst="rect">
@@ -5068,8 +5068,8 @@
         </p:nvSpPr>
         <p:spPr>
           <a:xfrm>
-            <a:off x="596900" y="3048000"/>
-            <a:ext cx="1365250" cy="254000"/>
+            <a:off x="596900" y="3086100"/>
+            <a:ext cx="1365250" cy="266700"/>
           </a:xfrm>
           <a:prstGeom prst="roundRect">
             <a:avLst>
@@ -5114,7 +5114,7 @@
         </p:nvSpPr>
         <p:spPr>
           <a:xfrm>
-            <a:off x="2032000" y="3098800"/>
+            <a:off x="2032000" y="3143250"/>
             <a:ext cx="1905000" cy="165100"/>
           </a:xfrm>
           <a:prstGeom prst="rect">
@@ -5159,7 +5159,7 @@
         </p:nvSpPr>
         <p:spPr>
           <a:xfrm>
-            <a:off x="596900" y="3429000"/>
+            <a:off x="596900" y="3505200"/>
             <a:ext cx="4902200" cy="127000"/>
           </a:xfrm>
           <a:prstGeom prst="rect">
@@ -5204,8 +5204,8 @@
         </p:nvSpPr>
         <p:spPr>
           <a:xfrm>
-            <a:off x="596900" y="3594100"/>
-            <a:ext cx="3810000" cy="254000"/>
+            <a:off x="596900" y="3670300"/>
+            <a:ext cx="3810000" cy="266700"/>
           </a:xfrm>
           <a:prstGeom prst="roundRect">
             <a:avLst>
@@ -5250,7 +5250,7 @@
         </p:nvSpPr>
         <p:spPr>
           <a:xfrm>
-            <a:off x="4470400" y="3644900"/>
+            <a:off x="4470400" y="3727450"/>
             <a:ext cx="1016000" cy="165100"/>
           </a:xfrm>
           <a:prstGeom prst="rect">
@@ -5295,8 +5295,8 @@
         </p:nvSpPr>
         <p:spPr>
           <a:xfrm>
-            <a:off x="596900" y="4051300"/>
-            <a:ext cx="4851400" cy="546100"/>
+            <a:off x="596900" y="4140200"/>
+            <a:ext cx="4851400" cy="736600"/>
           </a:xfrm>
           <a:prstGeom prst="roundRect">
             <a:avLst>
@@ -5328,12 +5328,12 @@
           </a:fontRef>
         </p:style>
         <p:txBody>
-          <a:bodyPr rtlCol="0" anchor="ctr" wrap="square" lIns="114300" rIns="63500" tIns="38100" bIns="38100"/>
+          <a:bodyPr rtlCol="0" anchor="t" wrap="square" lIns="114300" rIns="63500" tIns="101600" bIns="38100"/>
           <a:lstStyle/>
           <a:p>
             <a:pPr algn="l">
               <a:lnSpc>
-                <a:spcPct val="125000"/>
+                <a:spcPct val="130000"/>
               </a:lnSpc>
               <a:spcBef>
                 <a:spcPts val="0"/>
@@ -5358,7 +5358,7 @@
                 <a:spcPct val="105000"/>
               </a:lnSpc>
               <a:spcBef>
-                <a:spcPts val="300"/>
+                <a:spcPts val="800"/>
               </a:spcBef>
               <a:spcAft>
                 <a:spcPts val="100"/>
@@ -5384,7 +5384,7 @@
         </p:nvCxnSpPr>
         <p:spPr>
           <a:xfrm>
-            <a:off x="596900" y="4749800"/>
+            <a:off x="596900" y="5105400"/>
             <a:ext cx="4851400" cy="0"/>
           </a:xfrm>
           <a:prstGeom prst="line">
@@ -5419,7 +5419,7 @@
         </p:nvSpPr>
         <p:spPr>
           <a:xfrm>
-            <a:off x="596900" y="4851400"/>
+            <a:off x="596900" y="5207000"/>
             <a:ext cx="4851400" cy="152400"/>
           </a:xfrm>
           <a:prstGeom prst="rect">
@@ -5464,7 +5464,7 @@
         </p:nvSpPr>
         <p:spPr>
           <a:xfrm>
-            <a:off x="596900" y="4991100"/>
+            <a:off x="596900" y="5359400"/>
             <a:ext cx="4851400" cy="152400"/>
           </a:xfrm>
           <a:prstGeom prst="rect">

</xml_diff>